<commit_message>
feat: video restructured: general approach and AI first, the bus as one example (4:09); deck regenerated
Co-Authored-By: Claude Sonnet 5.5 <noreply@anthropic.com>
Claude-Session: https://claude.ai/code/session_015FJt2Qsv88cxtF8e7yXTQp
</commit_message>
<xml_diff>
--- a/docs/final/demo_slides.pptx
+++ b/docs/final/demo_slides.pptx
@@ -509,7 +509,7 @@
           <a:lstStyle/>
           <a:p>
             <a:r>
-              <a:t>Most of this model was built on a bus. No laptop. Just my phone, and my voice. I spoke, Claude Code transcribed it, ran the experiments in the cloud, and sent back results I could read between stops. This is what AI-assisted actuarial work looks like when it leaves the desk.</a:t>
+              <a:t>I'm Kohei, and this is one pricing engine applied to two markets. Week one: a developed market with two point four million policy rows. Rank three of fifty-four. Week two: an emerging market with only two years of data, and a test book that is seventy-six percent new business. We finished second. The approach: keep what transfers from the developed market, re-measure what does not, and test every step in both directions. And AI works alongside me through all of it: exploring the data, writing and testing the code, running experiments, and checking its own work.</a:t>
             </a:r>
           </a:p>
         </p:txBody>
@@ -579,7 +579,7 @@
           <a:lstStyle/>
           <a:p>
             <a:r>
-              <a:t>Two weeks, two markets. Week one: a developed market with two point four million policy rows. Rank three of fifty-four. Week two: a new emerging market, only two years of data, and a test book that is seventy-six percent new business. We finished second.</a:t>
+              <a:t>So what changed in the new market? Motor claims are thirty-four percent more frequent, but forty-two percent cheaper. Glass, third-party and injury claims are far more frequent. Escape of water is far less. And three out of four test policies are brand-new customers with no history. We measured that these differences are stable across both years, instead of assuming it.</a:t>
             </a:r>
           </a:p>
         </p:txBody>
@@ -649,7 +649,7 @@
           <a:lstStyle/>
           <a:p>
             <a:r>
-              <a:t>So what changed in the new market? Motor claims are thirty-four percent more frequent, but forty-two percent cheaper. Glass, third-party and injury claims are far more frequent. Escape of water is far less. And three out of four test policies are brand-new customers with no history. We measured that these differences are stable across both years, instead of assuming it.</a:t>
+              <a:t>The method keeps what transfers, and re-measures what does not. A developed-market model, trained on the variables both markets share, ranks who is risky. I add last year's claim history. An ensemble of five tree models, seven neural nets and four Tweedie models averages out the noise. Then the emerging book sets the level: claim counts and winsorised severities for each peril, credibility-weighted, plus one gender factor. The emerging data decides how much. The developed data decides who.</a:t>
             </a:r>
           </a:p>
         </p:txBody>
@@ -719,7 +719,7 @@
           <a:lstStyle/>
           <a:p>
             <a:r>
-              <a:t>The method keeps what transfers, and re-measures what does not. A developed-market model, trained on the variables both markets share, ranks who is risky. I add last year's claim history. An ensemble of five tree models, seven neural nets and four Tweedie models averages out the noise. Then the emerging book sets the level: claim counts and winsorised severities for each peril, credibility-weighted, plus one gender factor. The emerging data decides how much. The developed data decides who.</a:t>
+              <a:t>With two years of data, a single split can mistake noise for signal. So every change is tested in both directions: calibrate on 2023 and score 2024, then the reverse. We keep it only if neither direction gets worse. That took the score from point one one one oh, for an emerging-only model, to point one four oh five. More than thirty ideas were rejected this way, including pooled training, a GLM blend and clipping of high predictions. A simulation with a known truth confirmed the level method, and a ceiling analysis showed that a perfect level is worth at most half of one hundredth.</a:t>
             </a:r>
           </a:p>
         </p:txBody>
@@ -789,7 +789,7 @@
           <a:lstStyle/>
           <a:p>
             <a:r>
-              <a:t>With two years of data, a single split can mistake noise for signal. So every change is tested in both directions: calibrate on 2023 and score 2024, then the reverse. We keep it only if neither direction gets worse. That took the score from point one one one oh, for an emerging-only model, to point one four oh five. More than thirty ideas were rejected this way, including pooled training, a GLM blend and clipping of high predictions. A simulation with a known truth confirmed the level method, and a ceiling analysis showed that a perfect level is worth at most half of one hundredth.</a:t>
+              <a:t>Here is how that looked in practice. Claude Code explored both markets, wrote the code with one hundred and twenty-five tests, and ran the experiments, while more than ten helper sessions refit models in parallel. A blind second agent compared the markets from the raw tables alone. And verification caught real errors: unsupported statements in a first draft, a simulator bug that looked like a model bias, and a net that Part one had already rejected. Every number traces to a command.</a:t>
             </a:r>
           </a:p>
         </p:txBody>
@@ -859,7 +859,7 @@
           <a:lstStyle/>
           <a:p>
             <a:r>
-              <a:t>AI was part of every step. Claude Code explored both markets, wrote the code with one hundred and twenty-five tests, and ran the experiments, while more than ten helper sessions refit models in parallel. A blind second agent compared the markets from the raw tables alone. And verification caught real errors: unsupported statements in a first draft, a simulator bug that looked like a model bias, and a net that Part one had already rejected. Every number traces to a command.</a:t>
+              <a:t>One example of how this changes the way I work. Part of week two was modelled from my phone, on a bus, with no laptop. I spoke my instructions, Claude Code transcribed them, ran the experiments in the cloud, and sent back results I could read between stops. That is AI-assisted actuarial work, away from the desk.</a:t>
             </a:r>
           </a:p>
         </p:txBody>
@@ -4007,7 +4007,7 @@
       <p:grpSpPr/>
       <p:pic>
         <p:nvPicPr>
-          <p:cNvPr id="2" name="Picture 1" descr="slide_bus_0.png"/>
+          <p:cNvPr id="2" name="Picture 1" descr="slide_approach_0.png"/>
           <p:cNvPicPr>
             <a:picLocks noChangeAspect="1"/>
           </p:cNvPicPr>
@@ -4049,7 +4049,7 @@
       <p:grpSpPr/>
       <p:pic>
         <p:nvPicPr>
-          <p:cNvPr id="2" name="Picture 1" descr="slide_result_0.png"/>
+          <p:cNvPr id="2" name="Picture 1" descr="slide_changed_0.png"/>
           <p:cNvPicPr>
             <a:picLocks noChangeAspect="1"/>
           </p:cNvPicPr>
@@ -4091,7 +4091,7 @@
       <p:grpSpPr/>
       <p:pic>
         <p:nvPicPr>
-          <p:cNvPr id="2" name="Picture 1" descr="slide_changed_0.png"/>
+          <p:cNvPr id="2" name="Picture 1" descr="slide_method_0.png"/>
           <p:cNvPicPr>
             <a:picLocks noChangeAspect="1"/>
           </p:cNvPicPr>
@@ -4133,7 +4133,7 @@
       <p:grpSpPr/>
       <p:pic>
         <p:nvPicPr>
-          <p:cNvPr id="2" name="Picture 1" descr="slide_method_0.png"/>
+          <p:cNvPr id="2" name="Picture 1" descr="slide_trust_0.png"/>
           <p:cNvPicPr>
             <a:picLocks noChangeAspect="1"/>
           </p:cNvPicPr>
@@ -4175,7 +4175,7 @@
       <p:grpSpPr/>
       <p:pic>
         <p:nvPicPr>
-          <p:cNvPr id="2" name="Picture 1" descr="slide_trust_0.png"/>
+          <p:cNvPr id="2" name="Picture 1" descr="slide_ai_0.png"/>
           <p:cNvPicPr>
             <a:picLocks noChangeAspect="1"/>
           </p:cNvPicPr>
@@ -4217,7 +4217,7 @@
       <p:grpSpPr/>
       <p:pic>
         <p:nvPicPr>
-          <p:cNvPr id="2" name="Picture 1" descr="slide_ai_0.png"/>
+          <p:cNvPr id="2" name="Picture 1" descr="slide_bus_0.png"/>
           <p:cNvPicPr>
             <a:picLocks noChangeAspect="1"/>
           </p:cNvPicPr>

</xml_diff>

<commit_message>
feat: real phone footage (Claude Code remote control + voice), final ensemble structure scene, Week 2 private result removed, tools stated
Co-Authored-By: Claude Sonnet 5.5 <noreply@anthropic.com>
Claude-Session: https://claude.ai/code/session_015FJt2Qsv88cxtF8e7yXTQp
</commit_message>
<xml_diff>
--- a/docs/final/demo_slides.pptx
+++ b/docs/final/demo_slides.pptx
@@ -13,6 +13,7 @@
     <p:sldId id="261" r:id="rId13"/>
     <p:sldId id="262" r:id="rId14"/>
     <p:sldId id="263" r:id="rId15"/>
+    <p:sldId id="264" r:id="rId16"/>
   </p:sldIdLst>
   <p:sldSz cx="12191695" cy="6858000" type="screen4x3"/>
   <p:notesSz cx="6858000" cy="9144000"/>
@@ -509,7 +510,7 @@
           <a:lstStyle/>
           <a:p>
             <a:r>
-              <a:t>I'm Kohei, and this is one pricing engine applied to two markets. Week one: a developed market with two point four million policy rows. Rank three of fifty-four. Week two: an emerging market with only two years of data, and a test book that is seventy-six percent new business. We finished second. The approach: keep what transfers from the developed market, re-measure what does not, and test every step in both directions. And AI works alongside me through all of it: exploring the data, writing and testing the code, running experiments, and checking its own work.</a:t>
+              <a:t>I'm Kohei, and this is one pricing engine applied to two markets. Week one: a developed market with two point four million policy rows. Rank three of fifty-four. Week two: an emerging market with only two years of data, and a test book that is seventy-six percent new business. Our final file scored point one six four six on the public leaderboard. The approach: keep what transfers from the developed market, re-measure what does not, and test every step in both directions. And AI works alongside me throughout: I used Claude Code, steered from my phone by voice, to explore the data, write and test code, run experiments, and verify its own work.</a:t>
             </a:r>
           </a:p>
         </p:txBody>
@@ -719,7 +720,7 @@
           <a:lstStyle/>
           <a:p>
             <a:r>
-              <a:t>With two years of data, a single split can mistake noise for signal. So every change is tested in both directions: calibrate on 2023 and score 2024, then the reverse. We keep it only if neither direction gets worse. That took the score from point one one one oh, for an emerging-only model, to point one four oh five. More than thirty ideas were rejected this way, including pooled training, a GLM blend and clipping of high predictions. A simulation with a known truth confirmed the level method, and a ceiling analysis showed that a perfect level is worth at most half of one hundredth.</a:t>
+              <a:t>Here is the structure of the final submission. Five tree models: LightGBM with four and eight leaves, single and three-seed fits, a column-sampled variant, and an XGBoost model. Seven neural nets: TabM, TabM with piecewise-linear encoding, and TabM with quantile inputs, each as a single and a three-seed fit, plus one wider TabM. Four direct Tweedie models complete it, at four and eight leaves, single and three-seed. Each group is averaged with equal weights: trees and nets thirty-seven and a half percent each, Tweedie twenty-five. Then the emerging level and the gender factor are applied.</a:t>
             </a:r>
           </a:p>
         </p:txBody>
@@ -789,7 +790,7 @@
           <a:lstStyle/>
           <a:p>
             <a:r>
-              <a:t>Here is how that looked in practice. Claude Code explored both markets, wrote the code with one hundred and twenty-five tests, and ran the experiments, while more than ten helper sessions refit models in parallel. A blind second agent compared the markets from the raw tables alone. And verification caught real errors: unsupported statements in a first draft, a simulator bug that looked like a model bias, and a net that Part one had already rejected. Every number traces to a command.</a:t>
+              <a:t>With two years of data, a single split can mistake noise for signal. So every change is tested in both directions, calibrating on 2023 and scoring 2024 and the reverse, and kept only if neither gets worse. That took the score from point one one one oh, for an emerging-only model, to point one four oh five. More than thirty ideas were rejected this way, including pooled training and a GLM blend. A simulation with a known truth confirmed the level method, and a ceiling analysis showed that a perfect level is worth at most half of one hundredth.</a:t>
             </a:r>
           </a:p>
         </p:txBody>
@@ -859,7 +860,7 @@
           <a:lstStyle/>
           <a:p>
             <a:r>
-              <a:t>One example of how this changes the way I work. Part of week two was modelled from my phone, on a bus, with no laptop. I spoke my instructions, Claude Code transcribed them, ran the experiments in the cloud, and sent back results I could read between stops. That is AI-assisted actuarial work, away from the desk.</a:t>
+              <a:t>Here is how that looked in practice. Claude Code explored both markets, wrote the code with one hundred and twenty-five tests, and ran the experiments, while more than ten helper sessions refit models in parallel. A blind second agent compared the markets from the raw tables alone. And verification caught real errors: unsupported statements in a first draft, a simulator bug that looked like a model bias, and a net that Part one had already rejected. Every number traces to a command.</a:t>
             </a:r>
           </a:p>
         </p:txBody>
@@ -929,7 +930,7 @@
           <a:lstStyle/>
           <a:p>
             <a:r>
-              <a:t>Guardrails: a leak alarm, reproducibility checks, a model card, and eighty-four recorded decisions. The biggest uncertainty is the buildings level. Plus or minus twenty percent is about one hundredth of a point. And gender rating is flagged for regulatory review.</a:t>
+              <a:t>One example of how this changes the way I work. Part of week two was done from my phone, on a bus, with no laptop. Claude Code ran in the cloud, and I controlled it remotely from the Claude app. I gave my instructions by voice. The app transcribes my speech, Claude Code picks it up, runs the work, and reports back while I am on the move. That is AI-assisted actuarial work, away from the desk.</a:t>
             </a:r>
           </a:p>
         </p:txBody>
@@ -955,6 +956,76 @@
 </file>
 
 <file path=ppt/notesSlides/notesSlide8.xml><?xml version="1.0" encoding="utf-8"?>
+<p:notes xmlns:a="http://schemas.openxmlformats.org/drawingml/2006/main" xmlns:p="http://schemas.openxmlformats.org/presentationml/2006/main" xmlns:r="http://schemas.openxmlformats.org/officeDocument/2006/relationships">
+  <p:cSld>
+    <p:spTree>
+      <p:nvGrpSpPr>
+        <p:cNvPr id="1" name=""/>
+        <p:cNvGrpSpPr/>
+        <p:nvPr/>
+      </p:nvGrpSpPr>
+      <p:grpSpPr>
+        <a:xfrm>
+          <a:off x="0" y="0"/>
+          <a:ext cx="0" cy="0"/>
+          <a:chOff x="0" y="0"/>
+          <a:chExt cx="0" cy="0"/>
+        </a:xfrm>
+      </p:grpSpPr>
+      <p:sp>
+        <p:nvSpPr>
+          <p:cNvPr id="2" name="Slide Image Placeholder 1"/>
+          <p:cNvSpPr>
+            <a:spLocks noGrp="1"/>
+          </p:cNvSpPr>
+          <p:nvPr>
+            <p:ph type="sldImg" idx="2"/>
+          </p:nvPr>
+        </p:nvSpPr>
+        <p:spPr/>
+      </p:sp>
+      <p:sp>
+        <p:nvSpPr>
+          <p:cNvPr id="3" name="Notes Placeholder 2"/>
+          <p:cNvSpPr>
+            <a:spLocks noGrp="1"/>
+          </p:cNvSpPr>
+          <p:nvPr>
+            <p:ph type="body" idx="3" sz="quarter"/>
+          </p:nvPr>
+        </p:nvSpPr>
+        <p:spPr/>
+        <p:txBody>
+          <a:bodyPr/>
+          <a:lstStyle/>
+          <a:p>
+            <a:r>
+              <a:t>Guardrails: a leak alarm, reproducibility checks, a model card, and eighty-four recorded decisions. The biggest uncertainty is the buildings level. Plus or minus twenty percent is about one hundredth of a point. And gender rating is flagged for regulatory review.</a:t>
+            </a:r>
+          </a:p>
+        </p:txBody>
+      </p:sp>
+      <p:sp>
+        <p:nvSpPr>
+          <p:cNvPr id="4" name="Slide Number Placeholder 3"/>
+          <p:cNvSpPr>
+            <a:spLocks noGrp="1"/>
+          </p:cNvSpPr>
+          <p:nvPr>
+            <p:ph type="sldNum" idx="5" sz="quarter"/>
+          </p:nvPr>
+        </p:nvSpPr>
+        <p:spPr/>
+      </p:sp>
+    </p:spTree>
+  </p:cSld>
+  <p:clrMapOvr>
+    <a:masterClrMapping/>
+  </p:clrMapOvr>
+</p:notes>
+</file>
+
+<file path=ppt/notesSlides/notesSlide9.xml><?xml version="1.0" encoding="utf-8"?>
 <p:notes xmlns:a="http://schemas.openxmlformats.org/drawingml/2006/main" xmlns:p="http://schemas.openxmlformats.org/presentationml/2006/main" xmlns:r="http://schemas.openxmlformats.org/officeDocument/2006/relationships">
   <p:cSld>
     <p:spTree>
@@ -4133,7 +4204,7 @@
       <p:grpSpPr/>
       <p:pic>
         <p:nvPicPr>
-          <p:cNvPr id="2" name="Picture 1" descr="slide_trust_0.png"/>
+          <p:cNvPr id="2" name="Picture 1" descr="slide_ensemble_0.png"/>
           <p:cNvPicPr>
             <a:picLocks noChangeAspect="1"/>
           </p:cNvPicPr>
@@ -4175,7 +4246,7 @@
       <p:grpSpPr/>
       <p:pic>
         <p:nvPicPr>
-          <p:cNvPr id="2" name="Picture 1" descr="slide_ai_0.png"/>
+          <p:cNvPr id="2" name="Picture 1" descr="slide_trust_0.png"/>
           <p:cNvPicPr>
             <a:picLocks noChangeAspect="1"/>
           </p:cNvPicPr>
@@ -4217,7 +4288,7 @@
       <p:grpSpPr/>
       <p:pic>
         <p:nvPicPr>
-          <p:cNvPr id="2" name="Picture 1" descr="slide_bus_0.png"/>
+          <p:cNvPr id="2" name="Picture 1" descr="slide_ai_0.png"/>
           <p:cNvPicPr>
             <a:picLocks noChangeAspect="1"/>
           </p:cNvPicPr>
@@ -4259,6 +4330,48 @@
       <p:grpSpPr/>
       <p:pic>
         <p:nvPicPr>
+          <p:cNvPr id="2" name="Picture 1" descr="slide_bus_0.png"/>
+          <p:cNvPicPr>
+            <a:picLocks noChangeAspect="1"/>
+          </p:cNvPicPr>
+          <p:nvPr/>
+        </p:nvPicPr>
+        <p:blipFill>
+          <a:blip r:embed="rId2"/>
+          <a:stretch>
+            <a:fillRect/>
+          </a:stretch>
+        </p:blipFill>
+        <p:spPr>
+          <a:xfrm>
+            <a:off x="0" y="0"/>
+            <a:ext cx="12191695" cy="6858000"/>
+          </a:xfrm>
+          <a:prstGeom prst="rect">
+            <a:avLst/>
+          </a:prstGeom>
+        </p:spPr>
+      </p:pic>
+    </p:spTree>
+  </p:cSld>
+  <p:clrMapOvr>
+    <a:masterClrMapping/>
+  </p:clrMapOvr>
+</p:sld>
+</file>
+
+<file path=ppt/slides/slide8.xml><?xml version="1.0" encoding="utf-8"?>
+<p:sld xmlns:a="http://schemas.openxmlformats.org/drawingml/2006/main" xmlns:p="http://schemas.openxmlformats.org/presentationml/2006/main" xmlns:r="http://schemas.openxmlformats.org/officeDocument/2006/relationships">
+  <p:cSld>
+    <p:spTree>
+      <p:nvGrpSpPr>
+        <p:cNvPr id="1" name=""/>
+        <p:cNvGrpSpPr/>
+        <p:nvPr/>
+      </p:nvGrpSpPr>
+      <p:grpSpPr/>
+      <p:pic>
+        <p:nvPicPr>
           <p:cNvPr id="2" name="Picture 1" descr="slide_guard_0.png"/>
           <p:cNvPicPr>
             <a:picLocks noChangeAspect="1"/>
@@ -4289,7 +4402,7 @@
 </p:sld>
 </file>
 
-<file path=ppt/slides/slide8.xml><?xml version="1.0" encoding="utf-8"?>
+<file path=ppt/slides/slide9.xml><?xml version="1.0" encoding="utf-8"?>
 <p:sld xmlns:a="http://schemas.openxmlformats.org/drawingml/2006/main" xmlns:p="http://schemas.openxmlformats.org/presentationml/2006/main" xmlns:r="http://schemas.openxmlformats.org/officeDocument/2006/relationships">
   <p:cSld>
     <p:spTree>

</xml_diff>

<commit_message>
fix: numerals in captions and narration (2.4 million, 54, 76%, 0.1646 ...); font options (--font) for the video renderer
Co-Authored-By: Claude Sonnet 5.5 <noreply@anthropic.com>
Claude-Session: https://claude.ai/code/session_015FJt2Qsv88cxtF8e7yXTQp
</commit_message>
<xml_diff>
--- a/docs/final/demo_slides.pptx
+++ b/docs/final/demo_slides.pptx
@@ -510,7 +510,7 @@
           <a:lstStyle/>
           <a:p>
             <a:r>
-              <a:t>I'm Kohei, and this is one pricing engine applied to two markets. Week one: a developed market with two point four million policy rows. Rank three of fifty-four. Week two: an emerging market with only two years of data, and a test book that is seventy-six percent new business. Our final file scored point one six four six on the public leaderboard. The approach: keep what transfers from the developed market, re-measure what does not, and test every step in both directions. And AI works alongside me throughout: I used Claude Code, steered from my phone by voice, to explore the data, write and test code, run experiments, and verify its own work.</a:t>
+              <a:t>I'm Kohei, and this is one pricing engine applied to two markets. Week 1: a developed market with 2.4 million policy rows. Rank 3 of 54. Week 2: an emerging market with only 2 years of data, and a test book that is 76% new business. Our final file scored 0.1646 on the public leaderboard. The approach: keep what transfers from the developed market, re-measure what does not, and test every step in both directions. And AI works alongside me throughout: I used Claude Code, steered from my phone by voice, to explore the data, write and test code, run experiments, and verify its own work.</a:t>
             </a:r>
           </a:p>
         </p:txBody>
@@ -580,7 +580,7 @@
           <a:lstStyle/>
           <a:p>
             <a:r>
-              <a:t>So what changed in the new market? Motor claims are thirty-four percent more frequent, but forty-two percent cheaper. Glass, third-party and injury claims are far more frequent. Escape of water is far less. And three out of four test policies are brand-new customers with no history. We measured that these differences are stable across both years, instead of assuming it.</a:t>
+              <a:t>So what changed in the new market? Motor claims are 34% more frequent, but 42% cheaper. Glass, third-party and injury claims are far more frequent. Escape of water is far less. And 3 out of 4 test policies are brand-new customers with no history. We measured that these differences are stable across both years, instead of assuming it.</a:t>
             </a:r>
           </a:p>
         </p:txBody>
@@ -650,7 +650,7 @@
           <a:lstStyle/>
           <a:p>
             <a:r>
-              <a:t>The method keeps what transfers, and re-measures what does not. A developed-market model, trained on the variables both markets share, ranks who is risky. I add last year's claim history. An ensemble of five tree models, seven neural nets and four Tweedie models averages out the noise. Then the emerging book sets the level: claim counts and winsorised severities for each peril, credibility-weighted, plus one gender factor. The emerging data decides how much. The developed data decides who.</a:t>
+              <a:t>The method keeps what transfers, and re-measures what does not. A developed-market model, trained on the variables both markets share, ranks who is risky. I add last year's claim history. An ensemble of 5 tree models, 7 neural nets and 4 Tweedie models averages out the noise. Then the emerging book sets the level: claim counts and winsorised severities for each peril, credibility-weighted, plus one gender factor. The emerging data decides how much. The developed data decides who.</a:t>
             </a:r>
           </a:p>
         </p:txBody>
@@ -720,7 +720,7 @@
           <a:lstStyle/>
           <a:p>
             <a:r>
-              <a:t>Here is the structure of the final submission. Five tree models: LightGBM with four and eight leaves, single and three-seed fits, a column-sampled variant, and an XGBoost model. Seven neural nets: TabM, TabM with piecewise-linear encoding, and TabM with quantile inputs, each as a single and a three-seed fit, plus one wider TabM. Four direct Tweedie models complete it, at four and eight leaves, single and three-seed. Each group is averaged with equal weights: trees and nets thirty-seven and a half percent each, Tweedie twenty-five. Then the emerging level and the gender factor are applied.</a:t>
+              <a:t>Here is the structure of the final submission. 5 tree models: LightGBM with 4 and 8 leaves, single and 3-seed fits, a column-sampled variant, and an XGBoost model. 7 neural nets: TabM, TabM with piecewise-linear encoding, and TabM with quantile inputs, each as a single and a 3-seed fit, plus one wider TabM. 4 direct Tweedie models complete it, at 4 and 8 leaves, single and 3-seed. Each group is averaged with equal weights: trees and nets 37.5% each, Tweedie 25%. Then the emerging level and the gender factor are applied.</a:t>
             </a:r>
           </a:p>
         </p:txBody>
@@ -790,7 +790,7 @@
           <a:lstStyle/>
           <a:p>
             <a:r>
-              <a:t>With two years of data, a single split can mistake noise for signal. So every change is tested in both directions, calibrating on 2023 and scoring 2024 and the reverse, and kept only if neither gets worse. That took the score from point one one one oh, for an emerging-only model, to point one four oh five. More than thirty ideas were rejected this way, including pooled training and a GLM blend. A simulation with a known truth confirmed the level method, and a ceiling analysis showed that a perfect level is worth at most half of one hundredth.</a:t>
+              <a:t>With 2 years of data, a single split can mistake noise for signal. So every change is tested in both directions, calibrating on 2023 and scoring 2024 and the reverse, and kept only if neither gets worse. That took the score from 0.1110, for an emerging-only model, to 0.1405. More than 30 ideas were rejected this way, including pooled training and a GLM blend. A simulation with a known truth confirmed the level method, and a ceiling analysis showed that a perfect level is worth at most 0.005.</a:t>
             </a:r>
           </a:p>
         </p:txBody>
@@ -860,7 +860,7 @@
           <a:lstStyle/>
           <a:p>
             <a:r>
-              <a:t>Here is how that looked in practice. Claude Code explored both markets, wrote the code with one hundred and twenty-five tests, and ran the experiments, while more than ten helper sessions refit models in parallel. A blind second agent compared the markets from the raw tables alone. And verification caught real errors: unsupported statements in a first draft, a simulator bug that looked like a model bias, and a net that Part one had already rejected. Every number traces to a command.</a:t>
+              <a:t>Here is how that looked in practice. Claude Code explored both markets, wrote the code with 125 tests, and ran the experiments, while more than 10 helper sessions refit models in parallel. A blind second agent compared the markets from the raw tables alone. And verification caught real errors: unsupported statements in a first draft, a simulator bug that looked like a model bias, and a net that Part 1 had already rejected. Every number traces to a command.</a:t>
             </a:r>
           </a:p>
         </p:txBody>
@@ -930,7 +930,7 @@
           <a:lstStyle/>
           <a:p>
             <a:r>
-              <a:t>One example of how this changes the way I work. Part of week two was done from my phone, on a bus, with no laptop. Claude Code ran in the cloud, and I controlled it remotely from the Claude app. I gave my instructions by voice. The app transcribes my speech, Claude Code picks it up, runs the work, and reports back while I am on the move. That is AI-assisted actuarial work, away from the desk.</a:t>
+              <a:t>One example of how this changes the way I work. Part of Week 2 was done from my phone, on a bus, with no laptop. Claude Code ran in the cloud, and I controlled it remotely from the Claude app. I gave my instructions by voice. The app transcribes my speech, Claude Code picks it up, runs the work, and reports back while I am on the move. That is AI-assisted actuarial work, away from the desk.</a:t>
             </a:r>
           </a:p>
         </p:txBody>
@@ -1000,7 +1000,7 @@
           <a:lstStyle/>
           <a:p>
             <a:r>
-              <a:t>Guardrails: a leak alarm, reproducibility checks, a model card, and eighty-four recorded decisions. The biggest uncertainty is the buildings level. Plus or minus twenty percent is about one hundredth of a point. And gender rating is flagged for regulatory review.</a:t>
+              <a:t>Guardrails: a leak alarm, reproducibility checks, a model card, and 84 recorded decisions. The biggest uncertainty is the buildings level. Plus or minus 20% is about 0.01 of D². And gender rating is flagged for regulatory review.</a:t>
             </a:r>
           </a:p>
         </p:txBody>

</xml_diff>